<commit_message>
Additional checks moved into the hand-in notebook; slow scoring cached, run 240 s
</commit_message>
<xml_diff>
--- a/presentation/Mini_Project_Presentation.pptx
+++ b/presentation/Mini_Project_Presentation.pptx
@@ -366,7 +366,7 @@
           </a:p>
           <a:p>
             <a:r>
-              <a:t>Before we start, we press Run All in the notebook. It runs everything from the raw CSV files, from top to bottom, and takes about two minutes; we will look at it twice during the talk. The trained models load from a saved cache, because training them all from scratch takes about 25 minutes.</a:t>
+              <a:t>Before we start, we press Run All in the notebook. It runs everything from the raw CSV files, from top to bottom, and takes about four minutes; we will look at it twice during the talk. The trained models load from a saved cache, because training them all from scratch takes about 25 minutes.</a:t>
             </a:r>
           </a:p>
           <a:p>
@@ -451,7 +451,7 @@
           </a:p>
           <a:p>
             <a:r>
-              <a:t>What would an attacker fake? I sorted the features by who controls them. 69% of the SHAP weight is on features the attacker can change cheaply, above all the TCP settings of their own machine. If every test attack simply copies the most common benign settings, and nothing else, boosting's recall drops to zero. A greedy attack search, in the separate notebook of extra checks, allowed only changes the attacker controls, needed a single change for all 50 attacks it tried. I will show that live after Part F, which Kirill presents now.</a:t>
+              <a:t>What would an attacker fake? I sorted the features by who controls them. 69% of the SHAP weight is on features the attacker can change cheaply, above all the TCP settings of their own machine. If every test attack simply copies the most common benign settings, and nothing else, boosting's recall drops to zero. A greedy attack search, among the additional checks at the end of the notebook, allowed only changes the attacker controls, needed a single change for all 50 attacks it tried. I will show that live after Part F, which Kirill presents now.</a:t>
             </a:r>
           </a:p>
         </p:txBody>
@@ -5228,7 +5228,7 @@
                   <a:srgbClr val="526173"/>
                 </a:solidFill>
               </a:rPr>
-              <a:t>Notebook Part E · results/tables/E4_feature_groups.csv, E4_whatif_benign_tcp.csv; separate notebook of additional checks</a:t>
+              <a:t>Notebook Part E · results/tables/E4_feature_groups.csv, E4_whatif_benign_tcp.csv; additional check X3, X3_attack_summary.csv</a:t>
             </a:r>
           </a:p>
         </p:txBody>
@@ -12225,7 +12225,7 @@
                   <a:srgbClr val="526173"/>
                 </a:solidFill>
               </a:rPr>
-              <a:t>Separate notebook of additional checks · results/figures/X4_learning_curve.png</a:t>
+              <a:t>Notebook, additional check X4 · results/figures/X4_learning_curve.png</a:t>
             </a:r>
           </a:p>
         </p:txBody>

</xml_diff>

<commit_message>
Two-phase notebook: every setting chosen on validation before the test set is opened
</commit_message>
<xml_diff>
--- a/presentation/Mini_Project_Presentation.pptx
+++ b/presentation/Mini_Project_Presentation.pptx
@@ -1036,7 +1036,7 @@
           </a:p>
           <a:p>
             <a:r>
-              <a:t>Two glass boxes, a decision tree and logistic regression, and one black box, gradient boosting. Every setting, the tree depth, the regularisation and the boosting grid, was chosen on the validation set, and the test set was used once at the end. Validation and test agree within 0.003 on every score.</a:t>
+              <a:t>Two glass boxes, a decision tree and logistic regression, and one black box, gradient boosting. Every setting, the tree depth, the regularisation and the boosting grid, was chosen on the validation set, and the notebook only opens the test set after all choices are made. Validation and test agree within 0.003 on every score.</a:t>
             </a:r>
           </a:p>
           <a:p>
@@ -1121,7 +1121,7 @@
           </a:p>
           <a:p>
             <a:r>
-              <a:t>This is the notebook we started almost three minutes ago. It is already past Part B: here is the test table, computed just now, with the same 0.972 as on the slide. It is now working through the explanation part. We come back at the end. Stefanos now takes Parts C, D and E.</a:t>
+              <a:t>This is the notebook we started almost three minutes ago. Every setting was chosen first, on validation, and only here is the test set opened. Here is the test table, computed just now, with the same 0.972 as on the slide. It is now working through the explanation part. We come back at the end. Stefanos now takes Parts C, D and E.</a:t>
             </a:r>
           </a:p>
         </p:txBody>
@@ -13378,7 +13378,7 @@
                   <a:srgbClr val="245CC5"/>
                 </a:solidFill>
               </a:rPr>
-              <a:t>Settings chosen on validation; test used once, and it agrees within 0.003.</a:t>
+              <a:t>Settings chosen on validation, test opened only after; they agree within 0.003.</a:t>
             </a:r>
           </a:p>
         </p:txBody>

</xml_diff>